<commit_message>
refactor: address code review — restructure ingestion, split dashboard, harden TLS, unify deps, expand tests
</commit_message>
<xml_diff>
--- a/Silent_Patient_Pool_Finder.pptx
+++ b/Silent_Patient_Pool_Finder.pptx
@@ -13,11 +13,13 @@
     <p:sldId id="261" r:id="rId7"/>
     <p:sldId id="262" r:id="rId8"/>
     <p:sldId id="263" r:id="rId9"/>
+    <p:sldId id="269" r:id="rId20"/>
     <p:sldId id="264" r:id="rId10"/>
     <p:sldId id="265" r:id="rId11"/>
     <p:sldId id="266" r:id="rId12"/>
     <p:sldId id="267" r:id="rId13"/>
     <p:sldId id="268" r:id="rId14"/>
+    <p:sldId id="270" r:id="rId21"/>
   </p:sldIdLst>
   <p:notesMasterIdLst>
     <p:notesMasterId r:id="rId15"/>
@@ -4280,6 +4282,734 @@
 </p:sld>
 </file>
 
+<file path=ppt/slides/slide14.xml><?xml version="1.0" encoding="utf-8"?>
+<p:sld xmlns:a="http://schemas.openxmlformats.org/drawingml/2006/main" xmlns:r="http://schemas.openxmlformats.org/officeDocument/2006/relationships" xmlns:p="http://schemas.openxmlformats.org/presentationml/2006/main">
+  <p:cSld name="Slide 8">
+    <p:bg>
+      <p:bgPr>
+        <a:solidFill>
+          <a:srgbClr val="F3F2F2"/>
+        </a:solidFill>
+      </p:bgPr>
+    </p:bg>
+    <p:spTree>
+      <p:nvGrpSpPr>
+        <p:cNvPr id="1" name=""/>
+        <p:cNvGrpSpPr/>
+        <p:nvPr/>
+      </p:nvGrpSpPr>
+      <p:grpSpPr>
+        <a:xfrm>
+          <a:off x="0" y="0"/>
+          <a:ext cx="0" cy="0"/>
+          <a:chOff x="0" y="0"/>
+          <a:chExt cx="0" cy="0"/>
+        </a:xfrm>
+      </p:grpSpPr>
+      <p:sp>
+        <p:nvSpPr>
+          <p:cNvPr id="2" name="Text 0"/>
+          <p:cNvSpPr/>
+          <p:nvPr/>
+        </p:nvSpPr>
+        <p:spPr>
+          <a:xfrm>
+            <a:off x="1348978" y="1623492"/>
+            <a:ext cx="17124164" cy="472083"/>
+          </a:xfrm>
+          <a:prstGeom prst="rect">
+            <a:avLst/>
+          </a:prstGeom>
+          <a:noFill/>
+          <a:ln/>
+        </p:spPr>
+        <p:txBody>
+          <a:bodyPr wrap="square" lIns="25400" tIns="25400" rIns="25400" bIns="25400" rtlCol="0" anchor="t">
+            <a:normAutofit/>
+          </a:bodyPr>
+          <a:lstStyle/>
+          <a:p>
+            <a:pPr algn="l" indent="0" marL="0">
+              <a:lnSpc>
+                <a:spcPct val="103846"/>
+              </a:lnSpc>
+              <a:buNone/>
+            </a:pPr>
+            <a:r>
+              <a:rPr lang="en-US" sz="5100" b="1" spc="-76" kern="0" dirty="0">
+                <a:solidFill>
+                  <a:srgbClr val="201E1D"/>
+                </a:solidFill>
+                <a:latin typeface="Arial" pitchFamily="34" charset="0"/>
+                <a:ea typeface="Arial" pitchFamily="34" charset="-122"/>
+                <a:cs typeface="Arial" pitchFamily="34" charset="-120"/>
+              </a:rPr>
+              <a:t>Does the score beat a spreadsheet?</a:t>
+            </a:r>
+            <a:endParaRPr lang="en-US" sz="5100" dirty="0"/>
+          </a:p>
+        </p:txBody>
+      </p:sp>
+      <p:sp>
+        <p:nvSpPr>
+          <p:cNvPr id="3" name="Text 1"/>
+          <p:cNvSpPr/>
+          <p:nvPr/>
+        </p:nvSpPr>
+        <p:spPr>
+          <a:xfrm>
+            <a:off x="1371600" y="4019104"/>
+            <a:ext cx="8046720" cy="267816"/>
+          </a:xfrm>
+          <a:prstGeom prst="rect">
+            <a:avLst/>
+          </a:prstGeom>
+          <a:noFill/>
+          <a:ln/>
+        </p:spPr>
+        <p:txBody>
+          <a:bodyPr wrap="square" lIns="25400" tIns="25400" rIns="25400" bIns="25400" rtlCol="0" anchor="t">
+            <a:normAutofit/>
+          </a:bodyPr>
+          <a:lstStyle/>
+          <a:p>
+            <a:pPr algn="l" indent="0" marL="0">
+              <a:lnSpc>
+                <a:spcPct val="98341"/>
+              </a:lnSpc>
+              <a:buNone/>
+            </a:pPr>
+            <a:r>
+              <a:rPr lang="en-US" sz="2700" b="1" spc="-40" kern="0" dirty="0">
+                <a:solidFill>
+                  <a:srgbClr val="201E1D"/>
+                </a:solidFill>
+                <a:latin typeface="Arial" pitchFamily="34" charset="0"/>
+                <a:ea typeface="Arial" pitchFamily="34" charset="-122"/>
+                <a:cs typeface="Arial" pitchFamily="34" charset="-120"/>
+              </a:rPr>
+              <a:t>Lift over a naive baseline</a:t>
+            </a:r>
+            <a:endParaRPr lang="en-US" sz="2700" dirty="0"/>
+          </a:p>
+        </p:txBody>
+      </p:sp>
+      <p:sp>
+        <p:nvSpPr>
+          <p:cNvPr id="4" name="Text 2"/>
+          <p:cNvSpPr/>
+          <p:nvPr/>
+        </p:nvSpPr>
+        <p:spPr>
+          <a:xfrm>
+            <a:off x="1371600" y="4533379"/>
+            <a:ext cx="7534656" cy="1258267"/>
+          </a:xfrm>
+          <a:prstGeom prst="rect">
+            <a:avLst/>
+          </a:prstGeom>
+          <a:noFill/>
+          <a:ln/>
+        </p:spPr>
+        <p:txBody>
+          <a:bodyPr wrap="square" lIns="25400" tIns="25400" rIns="25400" bIns="25400" rtlCol="0" anchor="t">
+            <a:normAutofit/>
+          </a:bodyPr>
+          <a:lstStyle/>
+          <a:p>
+            <a:pPr algn="just" indent="0" marL="0">
+              <a:lnSpc>
+                <a:spcPct val="156522"/>
+              </a:lnSpc>
+              <a:buNone/>
+            </a:pPr>
+            <a:r>
+              <a:rPr lang="en-US" sz="2250" dirty="0">
+                <a:solidFill>
+                  <a:srgbClr val="201E1D"/>
+                </a:solidFill>
+                <a:latin typeface="Arial" pitchFamily="34" charset="0"/>
+                <a:ea typeface="Arial" pitchFamily="34" charset="-122"/>
+                <a:cs typeface="Arial" pitchFamily="34" charset="-120"/>
+              </a:rPr>
+              <a:t>Every number is reported against the 5-minute Excel version — rank by population × prevalence. Ranking is judged on Spearman ρ; the model earns its keep only if it beats that. Δρ = [ __ ].</a:t>
+            </a:r>
+            <a:endParaRPr lang="en-US" sz="2250" dirty="0"/>
+          </a:p>
+        </p:txBody>
+      </p:sp>
+      <p:sp>
+        <p:nvSpPr>
+          <p:cNvPr id="5" name="Text 3"/>
+          <p:cNvSpPr/>
+          <p:nvPr/>
+        </p:nvSpPr>
+        <p:spPr>
+          <a:xfrm>
+            <a:off x="9601200" y="4019104"/>
+            <a:ext cx="8046720" cy="267816"/>
+          </a:xfrm>
+          <a:prstGeom prst="rect">
+            <a:avLst/>
+          </a:prstGeom>
+          <a:noFill/>
+          <a:ln/>
+        </p:spPr>
+        <p:txBody>
+          <a:bodyPr wrap="square" lIns="25400" tIns="25400" rIns="25400" bIns="25400" rtlCol="0" anchor="t">
+            <a:normAutofit/>
+          </a:bodyPr>
+          <a:lstStyle/>
+          <a:p>
+            <a:pPr algn="l" indent="0" marL="0">
+              <a:lnSpc>
+                <a:spcPct val="98341"/>
+              </a:lnSpc>
+              <a:buNone/>
+            </a:pPr>
+            <a:r>
+              <a:rPr lang="en-US" sz="2700" b="1" spc="-40" kern="0" dirty="0">
+                <a:solidFill>
+                  <a:srgbClr val="201E1D"/>
+                </a:solidFill>
+                <a:latin typeface="Arial" pitchFamily="34" charset="0"/>
+                <a:ea typeface="Arial" pitchFamily="34" charset="-122"/>
+                <a:cs typeface="Arial" pitchFamily="34" charset="-120"/>
+              </a:rPr>
+              <a:t>Temporal out-of-time test</a:t>
+            </a:r>
+            <a:endParaRPr lang="en-US" sz="2700" dirty="0"/>
+          </a:p>
+        </p:txBody>
+      </p:sp>
+      <p:sp>
+        <p:nvSpPr>
+          <p:cNvPr id="6" name="Text 4"/>
+          <p:cNvSpPr/>
+          <p:nvPr/>
+        </p:nvSpPr>
+        <p:spPr>
+          <a:xfrm>
+            <a:off x="9601200" y="4533379"/>
+            <a:ext cx="7534656" cy="1258267"/>
+          </a:xfrm>
+          <a:prstGeom prst="rect">
+            <a:avLst/>
+          </a:prstGeom>
+          <a:noFill/>
+          <a:ln/>
+        </p:spPr>
+        <p:txBody>
+          <a:bodyPr wrap="square" lIns="25400" tIns="25400" rIns="25400" bIns="25400" rtlCol="0" anchor="t">
+            <a:normAutofit/>
+          </a:bodyPr>
+          <a:lstStyle/>
+          <a:p>
+            <a:pPr algn="just" indent="0" marL="0">
+              <a:lnSpc>
+                <a:spcPct val="156522"/>
+              </a:lnSpc>
+              <a:buNone/>
+            </a:pPr>
+            <a:r>
+              <a:rPr lang="en-US" sz="2250" dirty="0">
+                <a:solidFill>
+                  <a:srgbClr val="201E1D"/>
+                </a:solidFill>
+                <a:latin typeface="Arial" pitchFamily="34" charset="0"/>
+                <a:ea typeface="Arial" pitchFamily="34" charset="-122"/>
+                <a:cs typeface="Arial" pitchFamily="34" charset="-120"/>
+              </a:rPr>
+              <a:t>Score frozen on the old PLACES vintage predicts the diagnosis-gap move in the new one — coherence, not curve-fitting. Runs today on repo data. ρ = [ __ ] vs baseline [ __ ].</a:t>
+            </a:r>
+            <a:endParaRPr lang="en-US" sz="2250" dirty="0"/>
+          </a:p>
+        </p:txBody>
+      </p:sp>
+      <p:sp>
+        <p:nvSpPr>
+          <p:cNvPr id="7" name="Text 5"/>
+          <p:cNvSpPr/>
+          <p:nvPr/>
+        </p:nvSpPr>
+        <p:spPr>
+          <a:xfrm>
+            <a:off x="1371600" y="6782246"/>
+            <a:ext cx="8046720" cy="267816"/>
+          </a:xfrm>
+          <a:prstGeom prst="rect">
+            <a:avLst/>
+          </a:prstGeom>
+          <a:noFill/>
+          <a:ln/>
+        </p:spPr>
+        <p:txBody>
+          <a:bodyPr wrap="square" lIns="25400" tIns="25400" rIns="25400" bIns="25400" rtlCol="0" anchor="t">
+            <a:normAutofit/>
+          </a:bodyPr>
+          <a:lstStyle/>
+          <a:p>
+            <a:pPr algn="l" indent="0" marL="0">
+              <a:lnSpc>
+                <a:spcPct val="98341"/>
+              </a:lnSpc>
+              <a:buNone/>
+            </a:pPr>
+            <a:r>
+              <a:rPr lang="en-US" sz="2700" b="1" spc="-40" kern="0" dirty="0">
+                <a:solidFill>
+                  <a:srgbClr val="201E1D"/>
+                </a:solidFill>
+                <a:latin typeface="Arial" pitchFamily="34" charset="0"/>
+                <a:ea typeface="Arial" pitchFamily="34" charset="-122"/>
+                <a:cs typeface="Arial" pitchFamily="34" charset="-120"/>
+              </a:rPr>
+              <a:t>Predicts a source it never saw</a:t>
+            </a:r>
+            <a:endParaRPr lang="en-US" sz="2700" dirty="0"/>
+          </a:p>
+        </p:txBody>
+      </p:sp>
+      <p:sp>
+        <p:nvSpPr>
+          <p:cNvPr id="8" name="Text 6"/>
+          <p:cNvSpPr/>
+          <p:nvPr/>
+        </p:nvSpPr>
+        <p:spPr>
+          <a:xfrm>
+            <a:off x="1371600" y="7296522"/>
+            <a:ext cx="7534656" cy="1258267"/>
+          </a:xfrm>
+          <a:prstGeom prst="rect">
+            <a:avLst/>
+          </a:prstGeom>
+          <a:noFill/>
+          <a:ln/>
+        </p:spPr>
+        <p:txBody>
+          <a:bodyPr wrap="square" lIns="25400" tIns="25400" rIns="25400" bIns="25400" rtlCol="0" anchor="t">
+            <a:normAutofit/>
+          </a:bodyPr>
+          <a:lstStyle/>
+          <a:p>
+            <a:pPr algn="just" indent="0" marL="0">
+              <a:lnSpc>
+                <a:spcPct val="156522"/>
+              </a:lnSpc>
+              <a:buNone/>
+            </a:pPr>
+            <a:r>
+              <a:rPr lang="en-US" sz="2250" dirty="0">
+                <a:solidFill>
+                  <a:srgbClr val="201E1D"/>
+                </a:solidFill>
+                <a:latin typeface="Arial" pitchFamily="34" charset="0"/>
+                <a:ea typeface="Arial" pitchFamily="34" charset="-122"/>
+                <a:cs typeface="Arial" pitchFamily="34" charset="-120"/>
+              </a:rPr>
+              <a:t>Held out USRDS CKD prevalence — never ingested — and the composite still tracks it. A model, not a restatement of its own inputs. ρ = [ __ ] vs baseline [ __ ].</a:t>
+            </a:r>
+            <a:endParaRPr lang="en-US" sz="2250" dirty="0"/>
+          </a:p>
+        </p:txBody>
+      </p:sp>
+      <p:sp>
+        <p:nvSpPr>
+          <p:cNvPr id="9" name="Text 7"/>
+          <p:cNvSpPr/>
+          <p:nvPr/>
+        </p:nvSpPr>
+        <p:spPr>
+          <a:xfrm>
+            <a:off x="9601200" y="6782246"/>
+            <a:ext cx="8046720" cy="267816"/>
+          </a:xfrm>
+          <a:prstGeom prst="rect">
+            <a:avLst/>
+          </a:prstGeom>
+          <a:noFill/>
+          <a:ln/>
+        </p:spPr>
+        <p:txBody>
+          <a:bodyPr wrap="square" lIns="25400" tIns="25400" rIns="25400" bIns="25400" rtlCol="0" anchor="t">
+            <a:normAutofit/>
+          </a:bodyPr>
+          <a:lstStyle/>
+          <a:p>
+            <a:pPr algn="l" indent="0" marL="0">
+              <a:lnSpc>
+                <a:spcPct val="98341"/>
+              </a:lnSpc>
+              <a:buNone/>
+            </a:pPr>
+            <a:r>
+              <a:rPr lang="en-US" sz="2700" b="1" spc="-40" kern="0" dirty="0">
+                <a:solidFill>
+                  <a:srgbClr val="201E1D"/>
+                </a:solidFill>
+                <a:latin typeface="Arial" pitchFamily="34" charset="0"/>
+                <a:ea typeface="Arial" pitchFamily="34" charset="-122"/>
+                <a:cs typeface="Arial" pitchFamily="34" charset="-120"/>
+              </a:rPr>
+              <a:t>More than a poverty map</a:t>
+            </a:r>
+            <a:endParaRPr lang="en-US" sz="2700" dirty="0"/>
+          </a:p>
+        </p:txBody>
+      </p:sp>
+      <p:sp>
+        <p:nvSpPr>
+          <p:cNvPr id="10" name="Text 8"/>
+          <p:cNvSpPr/>
+          <p:nvPr/>
+        </p:nvSpPr>
+        <p:spPr>
+          <a:xfrm>
+            <a:off x="9601200" y="7296522"/>
+            <a:ext cx="7534656" cy="1258267"/>
+          </a:xfrm>
+          <a:prstGeom prst="rect">
+            <a:avLst/>
+          </a:prstGeom>
+          <a:noFill/>
+          <a:ln/>
+        </p:spPr>
+        <p:txBody>
+          <a:bodyPr wrap="square" lIns="25400" tIns="25400" rIns="25400" bIns="25400" rtlCol="0" anchor="t">
+            <a:normAutofit/>
+          </a:bodyPr>
+          <a:lstStyle/>
+          <a:p>
+            <a:pPr algn="just" indent="0" marL="0">
+              <a:lnSpc>
+                <a:spcPct val="156522"/>
+              </a:lnSpc>
+              <a:buNone/>
+            </a:pPr>
+            <a:r>
+              <a:rPr lang="en-US" sz="2250" dirty="0">
+                <a:solidFill>
+                  <a:srgbClr val="201E1D"/>
+                </a:solidFill>
+                <a:latin typeface="Arial" pitchFamily="34" charset="0"/>
+                <a:ea typeface="Arial" pitchFamily="34" charset="-122"/>
+                <a:cs typeface="Arial" pitchFamily="34" charset="-120"/>
+              </a:rPr>
+              <a:t>Diagnosis Gap adds independent signal over an SDoH-only model: ΔR² = [ __ ]. If it added nothing, the honest read is “a well-built access map.” The test is built to be able to fail.</a:t>
+            </a:r>
+            <a:endParaRPr lang="en-US" sz="2250" dirty="0"/>
+          </a:p>
+        </p:txBody>
+      </p:sp>
+      <p:pic>
+        <p:nvPicPr>
+          <p:cNvPr id="11" name="Image 0" descr="preencoded.png">    </p:cNvPr>
+          <p:cNvPicPr>
+            <a:picLocks noChangeAspect="1"/>
+          </p:cNvPicPr>
+          <p:nvPr/>
+        </p:nvPicPr>
+        <p:blipFill>
+          <a:blip r:embed="rId1"/>
+          <a:stretch>
+            <a:fillRect/>
+          </a:stretch>
+        </p:blipFill>
+        <p:spPr>
+          <a:xfrm>
+            <a:off x="13990439" y="9771906"/>
+            <a:ext cx="2925961" cy="153144"/>
+          </a:xfrm>
+          <a:prstGeom prst="rect">
+            <a:avLst/>
+          </a:prstGeom>
+        </p:spPr>
+      </p:pic>
+    </p:spTree>
+  </p:cSld>
+  <p:clrMapOvr>
+    <a:masterClrMapping/>
+  </p:clrMapOvr>
+</p:sld>
+</file>
+
+<file path=ppt/slides/slide15.xml><?xml version="1.0" encoding="utf-8"?>
+<p:sld xmlns:a="http://schemas.openxmlformats.org/drawingml/2006/main" xmlns:r="http://schemas.openxmlformats.org/officeDocument/2006/relationships" xmlns:p="http://schemas.openxmlformats.org/presentationml/2006/main">
+  <p:cSld name="Slide 13">
+    <p:bg>
+      <p:bgPr>
+        <a:solidFill>
+          <a:srgbClr val="F3F2F2"/>
+        </a:solidFill>
+      </p:bgPr>
+    </p:bg>
+    <p:spTree>
+      <p:nvGrpSpPr>
+        <p:cNvPr id="1" name=""/>
+        <p:cNvGrpSpPr/>
+        <p:nvPr/>
+      </p:nvGrpSpPr>
+      <p:grpSpPr>
+        <a:xfrm>
+          <a:off x="0" y="0"/>
+          <a:ext cx="0" cy="0"/>
+          <a:chOff x="0" y="0"/>
+          <a:chExt cx="0" cy="0"/>
+        </a:xfrm>
+      </p:grpSpPr>
+      <p:sp>
+        <p:nvSpPr>
+          <p:cNvPr id="2" name="Text 0"/>
+          <p:cNvSpPr/>
+          <p:nvPr/>
+        </p:nvSpPr>
+        <p:spPr>
+          <a:xfrm>
+            <a:off x="1348978" y="1623492"/>
+            <a:ext cx="17124164" cy="472083"/>
+          </a:xfrm>
+          <a:prstGeom prst="rect">
+            <a:avLst/>
+          </a:prstGeom>
+          <a:noFill/>
+          <a:ln/>
+        </p:spPr>
+        <p:txBody>
+          <a:bodyPr wrap="square" lIns="25400" tIns="25400" rIns="25400" bIns="25400" rtlCol="0" anchor="t">
+            <a:normAutofit/>
+          </a:bodyPr>
+          <a:lstStyle/>
+          <a:p>
+            <a:pPr algn="l" indent="0" marL="0">
+              <a:lnSpc>
+                <a:spcPct val="103846"/>
+              </a:lnSpc>
+              <a:buNone/>
+            </a:pPr>
+            <a:r>
+              <a:rPr lang="en-US" sz="5100" b="1" spc="-76" kern="0" dirty="0">
+                <a:solidFill>
+                  <a:srgbClr val="201E1D"/>
+                </a:solidFill>
+                <a:latin typeface="Arial" pitchFamily="34" charset="0"/>
+                <a:ea typeface="Arial" pitchFamily="34" charset="-122"/>
+                <a:cs typeface="Arial" pitchFamily="34" charset="-120"/>
+              </a:rPr>
+              <a:t>Backup — if the analysts push harder</a:t>
+            </a:r>
+            <a:endParaRPr lang="en-US" sz="5100" dirty="0"/>
+          </a:p>
+        </p:txBody>
+      </p:sp>
+      <p:sp>
+        <p:nvSpPr>
+          <p:cNvPr id="3" name="Text 1"/>
+          <p:cNvSpPr/>
+          <p:nvPr/>
+        </p:nvSpPr>
+        <p:spPr>
+          <a:xfrm>
+            <a:off x="1371600" y="4019104"/>
+            <a:ext cx="7983855" cy="267816"/>
+          </a:xfrm>
+          <a:prstGeom prst="rect">
+            <a:avLst/>
+          </a:prstGeom>
+          <a:noFill/>
+          <a:ln/>
+        </p:spPr>
+        <p:txBody>
+          <a:bodyPr wrap="square" lIns="25400" tIns="25400" rIns="25400" bIns="25400" rtlCol="0" anchor="t">
+            <a:normAutofit/>
+          </a:bodyPr>
+          <a:lstStyle/>
+          <a:p>
+            <a:pPr algn="l" indent="0" marL="0">
+              <a:lnSpc>
+                <a:spcPct val="98341"/>
+              </a:lnSpc>
+              <a:buNone/>
+            </a:pPr>
+            <a:r>
+              <a:rPr lang="en-US" sz="2700" b="1" spc="-40" kern="0" dirty="0">
+                <a:solidFill>
+                  <a:srgbClr val="201E1D"/>
+                </a:solidFill>
+                <a:latin typeface="Arial" pitchFamily="34" charset="0"/>
+                <a:ea typeface="Arial" pitchFamily="34" charset="-122"/>
+                <a:cs typeface="Arial" pitchFamily="34" charset="-120"/>
+              </a:rPr>
+              <a:t>“Aren’t you just rediscovering poverty?”</a:t>
+            </a:r>
+            <a:endParaRPr lang="en-US" sz="2700" dirty="0"/>
+          </a:p>
+        </p:txBody>
+      </p:sp>
+      <p:sp>
+        <p:nvSpPr>
+          <p:cNvPr id="4" name="Text 2"/>
+          <p:cNvSpPr/>
+          <p:nvPr/>
+        </p:nvSpPr>
+        <p:spPr>
+          <a:xfrm>
+            <a:off x="1371600" y="4533379"/>
+            <a:ext cx="7475792" cy="4344367"/>
+          </a:xfrm>
+          <a:prstGeom prst="rect">
+            <a:avLst/>
+          </a:prstGeom>
+          <a:noFill/>
+          <a:ln/>
+        </p:spPr>
+        <p:txBody>
+          <a:bodyPr wrap="square" lIns="25400" tIns="25400" rIns="25400" bIns="25400" rtlCol="0" anchor="t">
+            <a:normAutofit/>
+          </a:bodyPr>
+          <a:lstStyle/>
+          <a:p>
+            <a:pPr algn="just" indent="0" marL="0">
+              <a:lnSpc>
+                <a:spcPct val="156522"/>
+              </a:lnSpc>
+              <a:buNone/>
+            </a:pPr>
+            <a:r>
+              <a:rPr lang="en-US" sz="2250" dirty="0">
+                <a:solidFill>
+                  <a:srgbClr val="201E1D"/>
+                </a:solidFill>
+                <a:latin typeface="Arial" pitchFamily="34" charset="0"/>
+                <a:ea typeface="Arial" pitchFamily="34" charset="-122"/>
+                <a:cs typeface="Arial" pitchFamily="34" charset="-120"/>
+              </a:rPr>
+              <a:t>No. Fit an SDoH-only baseline, then add the Diagnosis Gap dimension: it carries independent predictive value — ΔR² = [ __ ], partial r = [ __ ] controlling for social determinants. High-opportunity is not the same as high-deprivation; the gap dimension moves the ranking on its own. And every number is reported as lift over a population × prevalence baseline, so the composite must beat the naive map to survive at all. If it doesn’t on your data, that is a finding we report — not one we bury.</a:t>
+            </a:r>
+            <a:endParaRPr lang="en-US" sz="2250" dirty="0"/>
+          </a:p>
+        </p:txBody>
+      </p:sp>
+      <p:sp>
+        <p:nvSpPr>
+          <p:cNvPr id="5" name="Text 3"/>
+          <p:cNvSpPr/>
+          <p:nvPr/>
+        </p:nvSpPr>
+        <p:spPr>
+          <a:xfrm>
+            <a:off x="9658350" y="4019104"/>
+            <a:ext cx="7983855" cy="267816"/>
+          </a:xfrm>
+          <a:prstGeom prst="rect">
+            <a:avLst/>
+          </a:prstGeom>
+          <a:noFill/>
+          <a:ln/>
+        </p:spPr>
+        <p:txBody>
+          <a:bodyPr wrap="square" lIns="25400" tIns="25400" rIns="25400" bIns="25400" rtlCol="0" anchor="t">
+            <a:normAutofit/>
+          </a:bodyPr>
+          <a:lstStyle/>
+          <a:p>
+            <a:pPr algn="l" indent="0" marL="0">
+              <a:lnSpc>
+                <a:spcPct val="98341"/>
+              </a:lnSpc>
+              <a:buNone/>
+            </a:pPr>
+            <a:r>
+              <a:rPr lang="en-US" sz="2700" b="1" spc="-40" kern="0" dirty="0">
+                <a:solidFill>
+                  <a:srgbClr val="201E1D"/>
+                </a:solidFill>
+                <a:latin typeface="Arial" pitchFamily="34" charset="0"/>
+                <a:ea typeface="Arial" pitchFamily="34" charset="-122"/>
+                <a:cs typeface="Arial" pitchFamily="34" charset="-120"/>
+              </a:rPr>
+              <a:t>“Can we trust the undiagnosed number?”</a:t>
+            </a:r>
+            <a:endParaRPr lang="en-US" sz="2700" dirty="0"/>
+          </a:p>
+        </p:txBody>
+      </p:sp>
+      <p:sp>
+        <p:nvSpPr>
+          <p:cNvPr id="6" name="Text 4"/>
+          <p:cNvSpPr/>
+          <p:nvPr/>
+        </p:nvSpPr>
+        <p:spPr>
+          <a:xfrm>
+            <a:off x="9658350" y="4533379"/>
+            <a:ext cx="7475792" cy="3830017"/>
+          </a:xfrm>
+          <a:prstGeom prst="rect">
+            <a:avLst/>
+          </a:prstGeom>
+          <a:noFill/>
+          <a:ln/>
+        </p:spPr>
+        <p:txBody>
+          <a:bodyPr wrap="square" lIns="25400" tIns="25400" rIns="25400" bIns="25400" rtlCol="0" anchor="t">
+            <a:normAutofit/>
+          </a:bodyPr>
+          <a:lstStyle/>
+          <a:p>
+            <a:pPr algn="just" indent="0" marL="0">
+              <a:lnSpc>
+                <a:spcPct val="156522"/>
+              </a:lnSpc>
+              <a:buNone/>
+            </a:pPr>
+            <a:r>
+              <a:rPr lang="en-US" sz="2250" dirty="0">
+                <a:solidFill>
+                  <a:srgbClr val="201E1D"/>
+                </a:solidFill>
+                <a:latin typeface="Arial" pitchFamily="34" charset="0"/>
+                <a:ea typeface="Arial" pitchFamily="34" charset="-122"/>
+                <a:cs typeface="Arial" pitchFamily="34" charset="-120"/>
+              </a:rPr>
+              <a:t>Treat it as an interval, never a point: population × prevalence × (1 − diagnosis-rate proxy) × published undiagnosis rate, shown as a low–central–high band (e.g. 38k–52k, central 45k). The absolute count is labeled directional; the ranking is the robust deliverable. A backdated IQVIA claims cut then calibrates the count to real local diagnosis rates and runs one falsifiable test: does the public-data prioritization predict where diagnoses actually landed? If Δρ ≤ 0, the undiagnosed-targeting thesis is not supported — and we say so.</a:t>
+            </a:r>
+            <a:endParaRPr lang="en-US" sz="2250" dirty="0"/>
+          </a:p>
+        </p:txBody>
+      </p:sp>
+      <p:pic>
+        <p:nvPicPr>
+          <p:cNvPr id="7" name="Image 0" descr="preencoded.png">    </p:cNvPr>
+          <p:cNvPicPr>
+            <a:picLocks noChangeAspect="1"/>
+          </p:cNvPicPr>
+          <p:nvPr/>
+        </p:nvPicPr>
+        <p:blipFill>
+          <a:blip r:embed="rId1"/>
+          <a:stretch>
+            <a:fillRect/>
+          </a:stretch>
+        </p:blipFill>
+        <p:spPr>
+          <a:xfrm>
+            <a:off x="13860363" y="9771906"/>
+            <a:ext cx="3056037" cy="153144"/>
+          </a:xfrm>
+          <a:prstGeom prst="rect">
+            <a:avLst/>
+          </a:prstGeom>
+        </p:spPr>
+      </p:pic>
+    </p:spTree>
+  </p:cSld>
+  <p:clrMapOvr>
+    <a:masterClrMapping/>
+  </p:clrMapOvr>
+</p:sld>
+</file>
+
 <file path=ppt/slides/slide2.xml><?xml version="1.0" encoding="utf-8"?>
 <p:sld xmlns:a="http://schemas.openxmlformats.org/drawingml/2006/main" xmlns:r="http://schemas.openxmlformats.org/officeDocument/2006/relationships" xmlns:p="http://schemas.openxmlformats.org/presentationml/2006/main">
   <p:cSld name="Slide 2">

</xml_diff>